<commit_message>
HA: add workflow supplementary figure, equations, renumber supp figs, extend framework discussion, update title
Co-Authored-By: Tatsuki Onishi <bougtoir@gmail.com>
</commit_message>
<xml_diff>
--- a/medical_accident_its_analysis/manuscript/ha_supplementary_figures.pptx
+++ b/medical_accident_its_analysis/manuscript/ha_supplementary_figures.pptx
@@ -7,6 +7,7 @@
   <p:sldIdLst>
     <p:sldId id="256" r:id="rId7"/>
     <p:sldId id="257" r:id="rId8"/>
+    <p:sldId id="258" r:id="rId9"/>
   </p:sldIdLst>
   <p:sldSz cx="12191695" cy="6858000" type="screen4x3"/>
   <p:notesSz cx="6858000" cy="9144000"/>
@@ -6106,7 +6107,7 @@
         <p:spPr>
           <a:xfrm>
             <a:off x="1097280" y="1005840"/>
-            <a:ext cx="7132320" cy="4754880"/>
+            <a:ext cx="4279392" cy="4754880"/>
           </a:xfrm>
           <a:prstGeom prst="rect">
             <a:avLst/>
@@ -6137,7 +6138,7 @@
           <a:p>
             <a:r>
               <a:rPr sz="1400"/>
-              <a:t>Closed malpractice claims per 1,000 physicians by specialty, 2008–2024 (rates, not counts).</a:t>
+              <a:t>Sensitivity-analysis framework for evaluating malpractice-litigation risk as a healthcare workforce-allocation lever.</a:t>
             </a:r>
           </a:p>
         </p:txBody>
@@ -6192,6 +6193,106 @@
       <p:pic>
         <p:nvPicPr>
           <p:cNvPr id="3" name="Picture 2" descr="ha_Supplementary_Figure_2.png"/>
+          <p:cNvPicPr>
+            <a:picLocks noChangeAspect="1"/>
+          </p:cNvPicPr>
+          <p:nvPr/>
+        </p:nvPicPr>
+        <p:blipFill>
+          <a:blip r:embed="rId2"/>
+          <a:stretch>
+            <a:fillRect/>
+          </a:stretch>
+        </p:blipFill>
+        <p:spPr>
+          <a:xfrm>
+            <a:off x="1097280" y="1005840"/>
+            <a:ext cx="7132320" cy="4754880"/>
+          </a:xfrm>
+          <a:prstGeom prst="rect">
+            <a:avLst/>
+          </a:prstGeom>
+        </p:spPr>
+      </p:pic>
+      <p:sp>
+        <p:nvSpPr>
+          <p:cNvPr id="4" name="TextBox 3"/>
+          <p:cNvSpPr txBox="1"/>
+          <p:nvPr/>
+        </p:nvSpPr>
+        <p:spPr>
+          <a:xfrm>
+            <a:off x="457200" y="5943600"/>
+            <a:ext cx="11247120" cy="822960"/>
+          </a:xfrm>
+          <a:prstGeom prst="rect">
+            <a:avLst/>
+          </a:prstGeom>
+          <a:noFill/>
+        </p:spPr>
+        <p:txBody>
+          <a:bodyPr wrap="square">
+            <a:spAutoFit/>
+          </a:bodyPr>
+          <a:lstStyle/>
+          <a:p>
+            <a:r>
+              <a:rPr sz="1400"/>
+              <a:t>Closed malpractice claims per 1,000 physicians by specialty, 2008–2024 (rates, not counts).</a:t>
+            </a:r>
+          </a:p>
+        </p:txBody>
+      </p:sp>
+    </p:spTree>
+  </p:cSld>
+  <p:clrMapOvr>
+    <a:masterClrMapping/>
+  </p:clrMapOvr>
+</p:sld>
+</file>
+
+<file path=ppt/slides/slide3.xml><?xml version="1.0" encoding="utf-8"?>
+<p:sld xmlns:a="http://schemas.openxmlformats.org/drawingml/2006/main" xmlns:p="http://schemas.openxmlformats.org/presentationml/2006/main" xmlns:r="http://schemas.openxmlformats.org/officeDocument/2006/relationships">
+  <p:cSld>
+    <p:spTree>
+      <p:nvGrpSpPr>
+        <p:cNvPr id="1" name=""/>
+        <p:cNvGrpSpPr/>
+        <p:nvPr/>
+      </p:nvGrpSpPr>
+      <p:grpSpPr/>
+      <p:sp>
+        <p:nvSpPr>
+          <p:cNvPr id="2" name="TextBox 1"/>
+          <p:cNvSpPr txBox="1"/>
+          <p:nvPr/>
+        </p:nvSpPr>
+        <p:spPr>
+          <a:xfrm>
+            <a:off x="457200" y="182880"/>
+            <a:ext cx="11247120" cy="640080"/>
+          </a:xfrm>
+          <a:prstGeom prst="rect">
+            <a:avLst/>
+          </a:prstGeom>
+          <a:noFill/>
+        </p:spPr>
+        <p:txBody>
+          <a:bodyPr wrap="none">
+            <a:spAutoFit/>
+          </a:bodyPr>
+          <a:lstStyle/>
+          <a:p>
+            <a:r>
+              <a:rPr sz="2400" b="1"/>
+              <a:t>Supplementary Figure 3</a:t>
+            </a:r>
+          </a:p>
+        </p:txBody>
+      </p:sp>
+      <p:pic>
+        <p:nvPicPr>
+          <p:cNvPr id="3" name="Picture 2" descr="ha_Supplementary_Figure_3.png"/>
           <p:cNvPicPr>
             <a:picLocks noChangeAspect="1"/>
           </p:cNvPicPr>

</xml_diff>